<commit_message>
Update downloadable ePoster to v4 (231 calculations, new screenshots)
Co-Authored-By: Claude Opus 5.5 <noreply@anthropic.com>
Claude-Session: https://claude.ai/code/session_014deLQTWcfXrpdaoPq9dWKW
</commit_message>
<xml_diff>
--- a/anesocalc/asa2026/media/AnesCalc_ASA2026_ePoster.pptx
+++ b/anesocalc/asa2026/media/AnesCalc_ASA2026_ePoster.pptx
@@ -1016,34 +1016,6 @@
             <a:pPr marL="0" indent="0" algn="ctr">
               <a:buNone/>
             </a:pPr>
-            <a:r>
-              <a:rPr lang="en-US" sz="700" dirty="0">
-                <a:solidFill>
-                  <a:srgbClr val="5A6176"/>
-                </a:solidFill>
-                <a:latin typeface="Calibri" pitchFamily="34" charset="0"/>
-                <a:ea typeface="Calibri" pitchFamily="34" charset="-122"/>
-                <a:cs typeface="Calibri" pitchFamily="34" charset="-120"/>
-              </a:rPr>
-              <a:t>QR</a:t>
-            </a:r>
-            <a:endParaRPr lang="en-US" sz="700" dirty="0"/>
-          </a:p>
-          <a:p>
-            <a:pPr marL="0" indent="0" algn="ctr">
-              <a:buNone/>
-            </a:pPr>
-            <a:r>
-              <a:rPr lang="en-US" sz="700" dirty="0">
-                <a:solidFill>
-                  <a:srgbClr val="5A6176"/>
-                </a:solidFill>
-                <a:latin typeface="Calibri" pitchFamily="34" charset="0"/>
-                <a:ea typeface="Calibri" pitchFamily="34" charset="-122"/>
-                <a:cs typeface="Calibri" pitchFamily="34" charset="-120"/>
-              </a:rPr>
-              <a:t>[NEED: URL]</a:t>
-            </a:r>
             <a:endParaRPr lang="en-US" sz="700" dirty="0"/>
           </a:p>
         </p:txBody>
@@ -1309,7 +1281,7 @@
         </p:nvSpPr>
         <p:spPr>
           <a:xfrm>
-            <a:off x="384048" y="1536192"/>
+            <a:off x="384048" y="1515172"/>
             <a:ext cx="2944368" cy="777240"/>
           </a:xfrm>
           <a:prstGeom prst="rect">
@@ -1329,7 +1301,7 @@
               <a:buNone/>
             </a:pPr>
             <a:r>
-              <a:rPr lang="en-US" sz="750" dirty="0">
+              <a:rPr lang="en-US" sz="725" dirty="0">
                 <a:solidFill>
                   <a:srgbClr val="231F20"/>
                 </a:solidFill>
@@ -1337,10 +1309,10 @@
                 <a:ea typeface="Calibri" pitchFamily="34" charset="-122"/>
                 <a:cs typeface="Calibri" pitchFamily="34" charset="-120"/>
               </a:rPr>
-              <a:t>LLM-based AI has introduced a software development paradigm termed </a:t>
-            </a:r>
-            <a:r>
-              <a:rPr lang="en-US" sz="750" b="1" dirty="0">
+              <a:t>In the traditional software development pipeline, software engineering expertise often represents a bottleneck between ideation and a working prototype. Large language models (LLMs) have lowered this barrier, enabling end users, including clinicians, to translate novel ideas into functional applications tailored to their workflows through an emerging practice sometimes termed </a:t>
+            </a:r>
+            <a:r>
+              <a:rPr lang="en-US" sz="725" b="1" dirty="0">
                 <a:solidFill>
                   <a:srgbClr val="231F20"/>
                 </a:solidFill>
@@ -1348,10 +1320,10 @@
                 <a:ea typeface="Calibri" pitchFamily="34" charset="-122"/>
                 <a:cs typeface="Calibri" pitchFamily="34" charset="-120"/>
               </a:rPr>
-              <a:t>“vibe coding”</a:t>
-            </a:r>
-            <a:r>
-              <a:rPr lang="en-US" sz="750" dirty="0">
+              <a:t>“vibe coding.”</a:t>
+            </a:r>
+            <a:r>
+              <a:rPr lang="en-US" sz="725" dirty="0">
                 <a:solidFill>
                   <a:srgbClr val="231F20"/>
                 </a:solidFill>
@@ -1359,42 +1331,9 @@
                 <a:ea typeface="Calibri" pitchFamily="34" charset="-122"/>
                 <a:cs typeface="Calibri" pitchFamily="34" charset="-120"/>
               </a:rPr>
-              <a:t>: domain experts </a:t>
-            </a:r>
-            <a:r>
-              <a:rPr lang="en-US" sz="750" b="1" dirty="0">
-                <a:solidFill>
-                  <a:srgbClr val="231F20"/>
-                </a:solidFill>
-                <a:latin typeface="Calibri" pitchFamily="34" charset="0"/>
-                <a:ea typeface="Calibri" pitchFamily="34" charset="-122"/>
-                <a:cs typeface="Calibri" pitchFamily="34" charset="-120"/>
-              </a:rPr>
-              <a:t>without formal programming training</a:t>
-            </a:r>
-            <a:r>
-              <a:rPr lang="en-US" sz="750" dirty="0">
-                <a:solidFill>
-                  <a:srgbClr val="231F20"/>
-                </a:solidFill>
-                <a:latin typeface="Calibri" pitchFamily="34" charset="0"/>
-                <a:ea typeface="Calibri" pitchFamily="34" charset="-122"/>
-                <a:cs typeface="Calibri" pitchFamily="34" charset="-120"/>
-              </a:rPr>
-              <a:t> direct AI to iteratively generate, debug, and refine production-ready code through natural language. The bottleneck moves from programming skill to clinical domain expertise. The application shown here is a worked example — </a:t>
-            </a:r>
-            <a:r>
-              <a:rPr lang="en-US" sz="750" b="1" dirty="0">
-                <a:solidFill>
-                  <a:srgbClr val="231F20"/>
-                </a:solidFill>
-                <a:latin typeface="Calibri" pitchFamily="34" charset="0"/>
-                <a:ea typeface="Calibri" pitchFamily="34" charset="-122"/>
-                <a:cs typeface="Calibri" pitchFamily="34" charset="-120"/>
-              </a:rPr>
-              <a:t>the replicable workflow is the result.</a:t>
-            </a:r>
-            <a:endParaRPr lang="en-US" sz="750" dirty="0"/>
+              <a:t> The following workflow was used to develop an iOS application providing point-of-care anesthetic reference values.</a:t>
+            </a:r>
+            <a:endParaRPr lang="en-US" sz="725" dirty="0"/>
           </a:p>
         </p:txBody>
       </p:sp>
@@ -1406,7 +1345,7 @@
         </p:nvSpPr>
         <p:spPr>
           <a:xfrm>
-            <a:off x="274320" y="2532888"/>
+            <a:off x="301752" y="2596033"/>
             <a:ext cx="3163824" cy="3026664"/>
           </a:xfrm>
           <a:prstGeom prst="roundRect">
@@ -1428,7 +1367,7 @@
           <a:bodyPr/>
           <a:lstStyle/>
           <a:p>
-            <a:endParaRPr lang="en-US"/>
+            <a:endParaRPr lang="en-US" dirty="0"/>
           </a:p>
         </p:txBody>
       </p:sp>
@@ -1546,7 +1485,7 @@
         <p:spPr>
           <a:xfrm>
             <a:off x="420624" y="2999232"/>
-            <a:ext cx="2651760" cy="297180"/>
+            <a:ext cx="1450404" cy="297180"/>
           </a:xfrm>
           <a:prstGeom prst="roundRect">
             <a:avLst>
@@ -1646,7 +1585,7 @@
         <p:spPr>
           <a:xfrm>
             <a:off x="731520" y="3026664"/>
-            <a:ext cx="2267712" cy="242316"/>
+            <a:ext cx="1240345" cy="242316"/>
           </a:xfrm>
           <a:prstGeom prst="rect">
             <a:avLst/>
@@ -1754,7 +1693,7 @@
         <p:spPr>
           <a:xfrm>
             <a:off x="420624" y="3360420"/>
-            <a:ext cx="2651760" cy="297180"/>
+            <a:ext cx="1450404" cy="297180"/>
           </a:xfrm>
           <a:prstGeom prst="roundRect">
             <a:avLst>
@@ -1854,7 +1793,7 @@
         <p:spPr>
           <a:xfrm>
             <a:off x="731520" y="3387852"/>
-            <a:ext cx="2267712" cy="242316"/>
+            <a:ext cx="1240345" cy="242316"/>
           </a:xfrm>
           <a:prstGeom prst="rect">
             <a:avLst/>
@@ -1962,7 +1901,7 @@
         <p:spPr>
           <a:xfrm>
             <a:off x="420624" y="3721608"/>
-            <a:ext cx="2651760" cy="297180"/>
+            <a:ext cx="1450404" cy="297180"/>
           </a:xfrm>
           <a:prstGeom prst="roundRect">
             <a:avLst>
@@ -1989,72 +1928,6 @@
       </p:sp>
       <p:sp>
         <p:nvSpPr>
-          <p:cNvPr id="38" name="Shape 33"/>
-          <p:cNvSpPr/>
-          <p:nvPr/>
-        </p:nvSpPr>
-        <p:spPr>
-          <a:xfrm>
-            <a:off x="493776" y="3778758"/>
-            <a:ext cx="182880" cy="182880"/>
-          </a:xfrm>
-          <a:prstGeom prst="ellipse">
-            <a:avLst/>
-          </a:prstGeom>
-          <a:solidFill>
-            <a:srgbClr val="253E85"/>
-          </a:solidFill>
-          <a:ln/>
-        </p:spPr>
-        <p:txBody>
-          <a:bodyPr/>
-          <a:lstStyle/>
-          <a:p>
-            <a:endParaRPr lang="en-US"/>
-          </a:p>
-        </p:txBody>
-      </p:sp>
-      <p:sp>
-        <p:nvSpPr>
-          <p:cNvPr id="39" name="Text 34"/>
-          <p:cNvSpPr txBox="1"/>
-          <p:nvPr/>
-        </p:nvSpPr>
-        <p:spPr>
-          <a:xfrm>
-            <a:off x="493776" y="3778758"/>
-            <a:ext cx="182880" cy="182880"/>
-          </a:xfrm>
-          <a:prstGeom prst="rect">
-            <a:avLst/>
-          </a:prstGeom>
-          <a:noFill/>
-          <a:ln/>
-        </p:spPr>
-        <p:txBody>
-          <a:bodyPr wrap="square" lIns="0" tIns="0" rIns="0" bIns="0" rtlCol="0" anchor="ctr"/>
-          <a:lstStyle/>
-          <a:p>
-            <a:pPr marL="0" indent="0" algn="ctr">
-              <a:buNone/>
-            </a:pPr>
-            <a:r>
-              <a:rPr lang="en-US" sz="700" b="1" dirty="0">
-                <a:solidFill>
-                  <a:srgbClr val="FFFFFF"/>
-                </a:solidFill>
-                <a:latin typeface="Calibri" pitchFamily="34" charset="0"/>
-                <a:ea typeface="Calibri" pitchFamily="34" charset="-122"/>
-                <a:cs typeface="Calibri" pitchFamily="34" charset="-120"/>
-              </a:rPr>
-              <a:t>3</a:t>
-            </a:r>
-            <a:endParaRPr lang="en-US" sz="700" dirty="0"/>
-          </a:p>
-        </p:txBody>
-      </p:sp>
-      <p:sp>
-        <p:nvSpPr>
           <p:cNvPr id="40" name="Text 35"/>
           <p:cNvSpPr txBox="1"/>
           <p:nvPr/>
@@ -2062,7 +1935,7 @@
         <p:spPr>
           <a:xfrm>
             <a:off x="731520" y="3749040"/>
-            <a:ext cx="2267712" cy="242316"/>
+            <a:ext cx="1240345" cy="242316"/>
           </a:xfrm>
           <a:prstGeom prst="rect">
             <a:avLst/>
@@ -2170,7 +2043,7 @@
         <p:spPr>
           <a:xfrm>
             <a:off x="420624" y="4082796"/>
-            <a:ext cx="2651760" cy="297180"/>
+            <a:ext cx="1450404" cy="297180"/>
           </a:xfrm>
           <a:prstGeom prst="roundRect">
             <a:avLst>
@@ -2270,7 +2143,7 @@
         <p:spPr>
           <a:xfrm>
             <a:off x="731520" y="4110228"/>
-            <a:ext cx="2267712" cy="242316"/>
+            <a:ext cx="1240345" cy="242316"/>
           </a:xfrm>
           <a:prstGeom prst="rect">
             <a:avLst/>
@@ -2378,7 +2251,7 @@
         <p:spPr>
           <a:xfrm>
             <a:off x="420624" y="4443984"/>
-            <a:ext cx="2651760" cy="297180"/>
+            <a:ext cx="1450404" cy="297180"/>
           </a:xfrm>
           <a:prstGeom prst="roundRect">
             <a:avLst>
@@ -2478,7 +2351,7 @@
         <p:spPr>
           <a:xfrm>
             <a:off x="731520" y="4471416"/>
-            <a:ext cx="2267712" cy="242316"/>
+            <a:ext cx="1240345" cy="242316"/>
           </a:xfrm>
           <a:prstGeom prst="rect">
             <a:avLst/>
@@ -2586,7 +2459,7 @@
         <p:spPr>
           <a:xfrm>
             <a:off x="420624" y="4805172"/>
-            <a:ext cx="2651760" cy="297180"/>
+            <a:ext cx="1450404" cy="297180"/>
           </a:xfrm>
           <a:prstGeom prst="roundRect">
             <a:avLst>
@@ -2613,72 +2486,6 @@
       </p:sp>
       <p:sp>
         <p:nvSpPr>
-          <p:cNvPr id="56" name="Shape 51"/>
-          <p:cNvSpPr/>
-          <p:nvPr/>
-        </p:nvSpPr>
-        <p:spPr>
-          <a:xfrm>
-            <a:off x="493776" y="4862322"/>
-            <a:ext cx="182880" cy="182880"/>
-          </a:xfrm>
-          <a:prstGeom prst="ellipse">
-            <a:avLst/>
-          </a:prstGeom>
-          <a:solidFill>
-            <a:srgbClr val="253E85"/>
-          </a:solidFill>
-          <a:ln/>
-        </p:spPr>
-        <p:txBody>
-          <a:bodyPr/>
-          <a:lstStyle/>
-          <a:p>
-            <a:endParaRPr lang="en-US"/>
-          </a:p>
-        </p:txBody>
-      </p:sp>
-      <p:sp>
-        <p:nvSpPr>
-          <p:cNvPr id="57" name="Text 52"/>
-          <p:cNvSpPr txBox="1"/>
-          <p:nvPr/>
-        </p:nvSpPr>
-        <p:spPr>
-          <a:xfrm>
-            <a:off x="493776" y="4862322"/>
-            <a:ext cx="182880" cy="182880"/>
-          </a:xfrm>
-          <a:prstGeom prst="rect">
-            <a:avLst/>
-          </a:prstGeom>
-          <a:noFill/>
-          <a:ln/>
-        </p:spPr>
-        <p:txBody>
-          <a:bodyPr wrap="square" lIns="0" tIns="0" rIns="0" bIns="0" rtlCol="0" anchor="ctr"/>
-          <a:lstStyle/>
-          <a:p>
-            <a:pPr marL="0" indent="0" algn="ctr">
-              <a:buNone/>
-            </a:pPr>
-            <a:r>
-              <a:rPr lang="en-US" sz="700" b="1" dirty="0">
-                <a:solidFill>
-                  <a:srgbClr val="FFFFFF"/>
-                </a:solidFill>
-                <a:latin typeface="Calibri" pitchFamily="34" charset="0"/>
-                <a:ea typeface="Calibri" pitchFamily="34" charset="-122"/>
-                <a:cs typeface="Calibri" pitchFamily="34" charset="-120"/>
-              </a:rPr>
-              <a:t>6</a:t>
-            </a:r>
-            <a:endParaRPr lang="en-US" sz="700" dirty="0"/>
-          </a:p>
-        </p:txBody>
-      </p:sp>
-      <p:sp>
-        <p:nvSpPr>
           <p:cNvPr id="58" name="Text 53"/>
           <p:cNvSpPr txBox="1"/>
           <p:nvPr/>
@@ -2686,7 +2493,7 @@
         <p:spPr>
           <a:xfrm>
             <a:off x="731520" y="4832604"/>
-            <a:ext cx="2267712" cy="242316"/>
+            <a:ext cx="1240345" cy="242316"/>
           </a:xfrm>
           <a:prstGeom prst="rect">
             <a:avLst/>
@@ -2739,7 +2546,7 @@
         </p:nvSpPr>
         <p:spPr>
           <a:xfrm>
-            <a:off x="3172968" y="4119372"/>
+            <a:off x="2011766" y="4119372"/>
             <a:ext cx="20117" cy="946404"/>
           </a:xfrm>
           <a:prstGeom prst="rect">
@@ -2766,7 +2573,7 @@
         </p:nvSpPr>
         <p:spPr>
           <a:xfrm>
-            <a:off x="3072384" y="4119372"/>
+            <a:off x="1911182" y="4119372"/>
             <a:ext cx="120701" cy="20117"/>
           </a:xfrm>
           <a:prstGeom prst="rect">
@@ -2793,7 +2600,7 @@
         </p:nvSpPr>
         <p:spPr>
           <a:xfrm>
-            <a:off x="3072384" y="5065776"/>
+            <a:off x="1911182" y="5065776"/>
             <a:ext cx="120701" cy="20117"/>
           </a:xfrm>
           <a:prstGeom prst="rect">
@@ -2820,7 +2627,7 @@
         </p:nvSpPr>
         <p:spPr>
           <a:xfrm rot="16200000">
-            <a:off x="3044952" y="4082796"/>
+            <a:off x="1883750" y="4082796"/>
             <a:ext cx="91440" cy="91440"/>
           </a:xfrm>
           <a:prstGeom prst="triangle">
@@ -2847,7 +2654,7 @@
         </p:nvSpPr>
         <p:spPr>
           <a:xfrm rot="5400000">
-            <a:off x="3163824" y="4391406"/>
+            <a:off x="2002622" y="4391406"/>
             <a:ext cx="237744" cy="402336"/>
           </a:xfrm>
           <a:prstGeom prst="rect">
@@ -2886,7 +2693,7 @@
         </p:nvSpPr>
         <p:spPr>
           <a:xfrm>
-            <a:off x="420624" y="5236780"/>
+            <a:off x="420624" y="5151814"/>
             <a:ext cx="2871216" cy="219456"/>
           </a:xfrm>
           <a:prstGeom prst="rect">
@@ -3033,7 +2840,7 @@
       </p:sp>
       <p:pic>
         <p:nvPicPr>
-          <p:cNvPr id="68" name="Image 3" descr="shots/crop_01_calculator_inputs.png"/>
+          <p:cNvPr id="68" name="Image 3" descr="AnesCalc patient inputs screen"/>
           <p:cNvPicPr>
             <a:picLocks noChangeAspect="1"/>
           </p:cNvPicPr>
@@ -3047,8 +2854,8 @@
         </p:blipFill>
         <p:spPr>
           <a:xfrm>
-            <a:off x="4613148" y="1554480"/>
-            <a:ext cx="987552" cy="939866"/>
+            <a:off x="4613148" y="1682061"/>
+            <a:ext cx="987552" cy="684703"/>
           </a:xfrm>
           <a:prstGeom prst="rect">
             <a:avLst/>
@@ -3125,7 +2932,7 @@
       </p:sp>
       <p:pic>
         <p:nvPicPr>
-          <p:cNvPr id="71" name="Image 4" descr="shots/crop_02_results_nmb.png"/>
+          <p:cNvPr id="71" name="Image 4" descr="AnesCalc results dashboard with TIVA results"/>
           <p:cNvPicPr>
             <a:picLocks noChangeAspect="1"/>
           </p:cNvPicPr>
@@ -3139,8 +2946,8 @@
         </p:blipFill>
         <p:spPr>
           <a:xfrm>
-            <a:off x="5728716" y="1554480"/>
-            <a:ext cx="987552" cy="939866"/>
+            <a:off x="5728716" y="1682061"/>
+            <a:ext cx="987552" cy="684703"/>
           </a:xfrm>
           <a:prstGeom prst="rect">
             <a:avLst/>
@@ -3217,7 +3024,7 @@
       </p:sp>
       <p:pic>
         <p:nvPicPr>
-          <p:cNvPr id="74" name="Image 5" descr="shots/crop_03_drug_cards.png"/>
+          <p:cNvPr id="74" name="Image 5" descr="AnesCalc drug reference cards with 14 class filters"/>
           <p:cNvPicPr>
             <a:picLocks noChangeAspect="1"/>
           </p:cNvPicPr>
@@ -3231,8 +3038,8 @@
         </p:blipFill>
         <p:spPr>
           <a:xfrm>
-            <a:off x="6844284" y="1554480"/>
-            <a:ext cx="987552" cy="939866"/>
+            <a:off x="6844284" y="1682061"/>
+            <a:ext cx="987552" cy="684703"/>
           </a:xfrm>
           <a:prstGeom prst="rect">
             <a:avLst/>
@@ -3524,7 +3331,7 @@
                 <a:ea typeface="Calibri" pitchFamily="34" charset="-122"/>
                 <a:cs typeface="Calibri" pitchFamily="34" charset="-120"/>
               </a:rPr>
-              <a:t>236</a:t>
+              <a:t>231</a:t>
             </a:r>
             <a:endParaRPr lang="en-US" sz="1000" dirty="0"/>
           </a:p>
@@ -4228,7 +4035,7 @@
                 <a:ea typeface="Calibri" pitchFamily="34" charset="-122"/>
                 <a:cs typeface="Calibri" pitchFamily="34" charset="-120"/>
               </a:rPr>
-              <a:t>Clinical domains  </a:t>
+              <a:t>Clinical domains:  </a:t>
             </a:r>
             <a:r>
               <a:rPr lang="en-US" sz="660" dirty="0">
@@ -4349,7 +4156,7 @@
                 <a:ea typeface="Calibri" pitchFamily="34" charset="-122"/>
                 <a:cs typeface="Calibri" pitchFamily="34" charset="-120"/>
               </a:rPr>
-              <a:t>Drug reference cards  </a:t>
+              <a:t>Drug reference cards:  </a:t>
             </a:r>
             <a:r>
               <a:rPr lang="en-US" sz="660" dirty="0">
@@ -4470,7 +4277,7 @@
                 <a:ea typeface="Calibri" pitchFamily="34" charset="-122"/>
                 <a:cs typeface="Calibri" pitchFamily="34" charset="-120"/>
               </a:rPr>
-              <a:t>Bedside clinical tools  </a:t>
+              <a:t>Bedside clinical tools:  </a:t>
             </a:r>
             <a:r>
               <a:rPr lang="en-US" sz="660" dirty="0">
@@ -5166,7 +4973,7 @@
                 <a:ea typeface="Calibri" pitchFamily="34" charset="-122"/>
                 <a:cs typeface="Calibri" pitchFamily="34" charset="-120"/>
               </a:rPr>
-              <a:t>The workflow — not the app — is the transferable product. The same six steps apply to almost any clinical need:
+              <a:t>The workflow, not the app, is the transferable product. The same six steps apply to almost any clinical need:
 </a:t>
             </a:r>
             <a:r>
@@ -5196,8 +5003,8 @@
         </p:nvSpPr>
         <p:spPr>
           <a:xfrm>
-            <a:off x="9006840" y="2487168"/>
-            <a:ext cx="2910535" cy="2203704"/>
+            <a:off x="9006840" y="2456940"/>
+            <a:ext cx="2910535" cy="2253996"/>
           </a:xfrm>
           <a:prstGeom prst="roundRect">
             <a:avLst>
@@ -5230,7 +5037,7 @@
         </p:nvSpPr>
         <p:spPr>
           <a:xfrm>
-            <a:off x="9116568" y="2551176"/>
+            <a:off x="9116568" y="2520948"/>
             <a:ext cx="2691079" cy="182880"/>
           </a:xfrm>
           <a:prstGeom prst="rect">
@@ -5269,7 +5076,7 @@
         </p:nvSpPr>
         <p:spPr>
           <a:xfrm>
-            <a:off x="9116568" y="2734056"/>
+            <a:off x="9116568" y="2703828"/>
             <a:ext cx="2691079" cy="20117"/>
           </a:xfrm>
           <a:prstGeom prst="rect">
@@ -5296,7 +5103,7 @@
         </p:nvSpPr>
         <p:spPr>
           <a:xfrm>
-            <a:off x="9116568" y="2788920"/>
+            <a:off x="9116568" y="2725072"/>
             <a:ext cx="2691079" cy="146304"/>
           </a:xfrm>
           <a:prstGeom prst="rect">
@@ -5335,7 +5142,7 @@
         </p:nvSpPr>
         <p:spPr>
           <a:xfrm>
-            <a:off x="9116568" y="2921982"/>
+            <a:off x="9116568" y="2839628"/>
             <a:ext cx="2691079" cy="768096"/>
           </a:xfrm>
           <a:prstGeom prst="rect">
@@ -5364,7 +5171,7 @@
                 <a:cs typeface="Calibri" pitchFamily="34" charset="-120"/>
               </a:rPr>
               <a:t>• LLMs reason in language, not graphics — visual and UI design still require human iteration
-• Output is bounded by the model’s knowledge and the target platform’s SDK
+• Output is bounded by the model’s knowledge and the target platform’s Software Development Kit
 • Hardware and OS compatibility must be verified on real devices
 • Institutional IT and security policy may restrict custom software and PHI handling</a:t>
             </a:r>
@@ -5380,7 +5187,7 @@
         </p:nvSpPr>
         <p:spPr>
           <a:xfrm>
-            <a:off x="9116568" y="3739896"/>
+            <a:off x="9116568" y="3629813"/>
             <a:ext cx="2691079" cy="146304"/>
           </a:xfrm>
           <a:prstGeom prst="rect">
@@ -5419,7 +5226,7 @@
         </p:nvSpPr>
         <p:spPr>
           <a:xfrm>
-            <a:off x="9116568" y="3872958"/>
+            <a:off x="9116568" y="3745202"/>
             <a:ext cx="2691079" cy="219456"/>
           </a:xfrm>
           <a:prstGeom prst="rect">
@@ -5449,7 +5256,24 @@
               </a:rPr>
               <a:t>• iOS only; not a regulated medical device — every output requires clinician verification</a:t>
             </a:r>
-            <a:endParaRPr lang="en-US" sz="690" dirty="0"/>
+          </a:p>
+          <a:p>
+            <a:pPr>
+              <a:lnSpc>
+                <a:spcPct val="108000"/>
+              </a:lnSpc>
+            </a:pPr>
+            <a:r>
+              <a:rPr lang="en-US" sz="690" dirty="0">
+                <a:solidFill>
+                  <a:srgbClr val="231F20"/>
+                </a:solidFill>
+                <a:latin typeface="Calibri" pitchFamily="34" charset="0"/>
+                <a:ea typeface="Calibri" pitchFamily="34" charset="-122"/>
+                <a:cs typeface="Calibri" pitchFamily="34" charset="-120"/>
+              </a:rPr>
+              <a:t>• Final product capability is constrained by the LLM’s tooling — user-defined feature scope is bounded by what the model can generate</a:t>
+            </a:r>
           </a:p>
         </p:txBody>
       </p:sp>
@@ -5461,7 +5285,7 @@
         </p:nvSpPr>
         <p:spPr>
           <a:xfrm>
-            <a:off x="9116568" y="4142232"/>
+            <a:off x="9116568" y="4202748"/>
             <a:ext cx="2691079" cy="146304"/>
           </a:xfrm>
           <a:prstGeom prst="rect">
@@ -5500,7 +5324,7 @@
         </p:nvSpPr>
         <p:spPr>
           <a:xfrm>
-            <a:off x="9116568" y="4275294"/>
+            <a:off x="9116568" y="4315638"/>
             <a:ext cx="2691079" cy="237744"/>
           </a:xfrm>
           <a:prstGeom prst="rect">
@@ -6038,6 +5862,608 @@
               <a:t>andrew.peace@burrell.edu</a:t>
             </a:r>
             <a:endParaRPr lang="en-US" sz="760" dirty="0"/>
+          </a:p>
+        </p:txBody>
+      </p:sp>
+      <p:pic>
+        <p:nvPicPr>
+          <p:cNvPr id="147" name="Picture 146">
+            <a:extLst>
+              <a:ext uri="{FF2B5EF4-FFF2-40B4-BE49-F238E27FC236}">
+                <a16:creationId xmlns:a16="http://schemas.microsoft.com/office/drawing/2014/main" id="{F357CEBD-6BA2-7D0C-3843-651EE1466CEB}"/>
+              </a:ext>
+            </a:extLst>
+          </p:cNvPr>
+          <p:cNvPicPr>
+            <a:picLocks noChangeAspect="1"/>
+          </p:cNvPicPr>
+          <p:nvPr/>
+        </p:nvPicPr>
+        <p:blipFill>
+          <a:blip r:embed="rId9"/>
+          <a:stretch>
+            <a:fillRect/>
+          </a:stretch>
+        </p:blipFill>
+        <p:spPr>
+          <a:xfrm>
+            <a:off x="10482681" y="204826"/>
+            <a:ext cx="651053" cy="651053"/>
+          </a:xfrm>
+          <a:prstGeom prst="rect">
+            <a:avLst/>
+          </a:prstGeom>
+        </p:spPr>
+      </p:pic>
+      <p:sp>
+        <p:nvSpPr>
+          <p:cNvPr id="148" name="Text 34">
+            <a:extLst>
+              <a:ext uri="{FF2B5EF4-FFF2-40B4-BE49-F238E27FC236}">
+                <a16:creationId xmlns:a16="http://schemas.microsoft.com/office/drawing/2014/main" id="{E604F049-6004-A960-C674-C5D9C03B73E7}"/>
+              </a:ext>
+            </a:extLst>
+          </p:cNvPr>
+          <p:cNvSpPr txBox="1"/>
+          <p:nvPr/>
+        </p:nvSpPr>
+        <p:spPr>
+          <a:xfrm>
+            <a:off x="496673" y="3783745"/>
+            <a:ext cx="182880" cy="182880"/>
+          </a:xfrm>
+          <a:prstGeom prst="rect">
+            <a:avLst/>
+          </a:prstGeom>
+          <a:solidFill>
+            <a:srgbClr val="2E8B6A"/>
+          </a:solidFill>
+          <a:ln/>
+        </p:spPr>
+        <p:txBody>
+          <a:bodyPr wrap="square" lIns="0" tIns="0" rIns="0" bIns="0" rtlCol="0" anchor="ctr"/>
+          <a:lstStyle/>
+          <a:p>
+            <a:pPr marL="0" indent="0" algn="ctr">
+              <a:buNone/>
+            </a:pPr>
+            <a:r>
+              <a:rPr lang="en-US" sz="700" b="1" dirty="0">
+                <a:solidFill>
+                  <a:srgbClr val="FFFFFF"/>
+                </a:solidFill>
+                <a:latin typeface="Calibri" pitchFamily="34" charset="0"/>
+                <a:ea typeface="Calibri" pitchFamily="34" charset="-122"/>
+                <a:cs typeface="Calibri" pitchFamily="34" charset="-120"/>
+              </a:rPr>
+              <a:t>3</a:t>
+            </a:r>
+            <a:endParaRPr lang="en-US" sz="700" dirty="0"/>
+          </a:p>
+        </p:txBody>
+      </p:sp>
+      <p:sp>
+        <p:nvSpPr>
+          <p:cNvPr id="149" name="Text 52">
+            <a:extLst>
+              <a:ext uri="{FF2B5EF4-FFF2-40B4-BE49-F238E27FC236}">
+                <a16:creationId xmlns:a16="http://schemas.microsoft.com/office/drawing/2014/main" id="{67DA7B62-CD3D-73B0-22EF-999A49B066C6}"/>
+              </a:ext>
+            </a:extLst>
+          </p:cNvPr>
+          <p:cNvSpPr txBox="1"/>
+          <p:nvPr/>
+        </p:nvSpPr>
+        <p:spPr>
+          <a:xfrm>
+            <a:off x="493776" y="4865984"/>
+            <a:ext cx="182880" cy="182880"/>
+          </a:xfrm>
+          <a:prstGeom prst="rect">
+            <a:avLst/>
+          </a:prstGeom>
+          <a:solidFill>
+            <a:srgbClr val="2E8B6A"/>
+          </a:solidFill>
+          <a:ln/>
+        </p:spPr>
+        <p:txBody>
+          <a:bodyPr wrap="square" lIns="0" tIns="0" rIns="0" bIns="0" rtlCol="0" anchor="ctr"/>
+          <a:lstStyle/>
+          <a:p>
+            <a:pPr marL="0" indent="0" algn="ctr">
+              <a:buNone/>
+            </a:pPr>
+            <a:r>
+              <a:rPr lang="en-US" sz="700" b="1" dirty="0">
+                <a:solidFill>
+                  <a:srgbClr val="FFFFFF"/>
+                </a:solidFill>
+                <a:latin typeface="Calibri" pitchFamily="34" charset="0"/>
+                <a:ea typeface="Calibri" pitchFamily="34" charset="-122"/>
+                <a:cs typeface="Calibri" pitchFamily="34" charset="-120"/>
+              </a:rPr>
+              <a:t>6</a:t>
+            </a:r>
+            <a:endParaRPr lang="en-US" sz="700" dirty="0"/>
+          </a:p>
+        </p:txBody>
+      </p:sp>
+      <p:sp>
+        <p:nvSpPr>
+          <p:cNvPr id="150" name="TextBox 149">
+            <a:extLst>
+              <a:ext uri="{FF2B5EF4-FFF2-40B4-BE49-F238E27FC236}">
+                <a16:creationId xmlns:a16="http://schemas.microsoft.com/office/drawing/2014/main" id="{DC84B657-3D36-EF9B-4BE4-FC9EA0339062}"/>
+              </a:ext>
+            </a:extLst>
+          </p:cNvPr>
+          <p:cNvSpPr txBox="1"/>
+          <p:nvPr/>
+        </p:nvSpPr>
+        <p:spPr>
+          <a:xfrm>
+            <a:off x="418346" y="5375600"/>
+            <a:ext cx="496054" cy="107722"/>
+          </a:xfrm>
+          <a:prstGeom prst="rect">
+            <a:avLst/>
+          </a:prstGeom>
+          <a:noFill/>
+        </p:spPr>
+        <p:txBody>
+          <a:bodyPr wrap="square" lIns="0" tIns="0" rIns="0" bIns="0">
+            <a:spAutoFit/>
+          </a:bodyPr>
+          <a:lstStyle/>
+          <a:p>
+            <a:pPr algn="l"/>
+            <a:r>
+              <a:rPr sz="700" b="1" dirty="0">
+                <a:solidFill>
+                  <a:srgbClr val="1D2E54"/>
+                </a:solidFill>
+              </a:rPr>
+              <a:t>■ </a:t>
+            </a:r>
+            <a:r>
+              <a:rPr lang="en-US" sz="700" b="0" dirty="0">
+                <a:solidFill>
+                  <a:srgbClr val="555555"/>
+                </a:solidFill>
+              </a:rPr>
+              <a:t>User</a:t>
+            </a:r>
+            <a:r>
+              <a:rPr sz="700" b="0" dirty="0">
+                <a:solidFill>
+                  <a:srgbClr val="555555"/>
+                </a:solidFill>
+              </a:rPr>
+              <a:t>  </a:t>
+            </a:r>
+            <a:r>
+              <a:rPr sz="700" b="1" dirty="0">
+                <a:solidFill>
+                  <a:srgbClr val="2E8B6A"/>
+                </a:solidFill>
+              </a:rPr>
+              <a:t>■ </a:t>
+            </a:r>
+            <a:r>
+              <a:rPr sz="700" b="0" dirty="0">
+                <a:solidFill>
+                  <a:srgbClr val="555555"/>
+                </a:solidFill>
+              </a:rPr>
+              <a:t>AI</a:t>
+            </a:r>
+          </a:p>
+        </p:txBody>
+      </p:sp>
+      <p:pic>
+        <p:nvPicPr>
+          <p:cNvPr id="152" name="Picture 151">
+            <a:extLst>
+              <a:ext uri="{FF2B5EF4-FFF2-40B4-BE49-F238E27FC236}">
+                <a16:creationId xmlns:a16="http://schemas.microsoft.com/office/drawing/2014/main" id="{2B060B45-3BDF-FEF5-FDD2-147E79A14BA3}"/>
+              </a:ext>
+            </a:extLst>
+          </p:cNvPr>
+          <p:cNvPicPr>
+            <a:picLocks noChangeAspect="1"/>
+          </p:cNvPicPr>
+          <p:nvPr/>
+        </p:nvPicPr>
+        <p:blipFill>
+          <a:blip r:embed="rId10"/>
+          <a:stretch>
+            <a:fillRect/>
+          </a:stretch>
+        </p:blipFill>
+        <p:spPr>
+          <a:xfrm>
+            <a:off x="2550978" y="2993618"/>
+            <a:ext cx="298484" cy="298484"/>
+          </a:xfrm>
+          <a:prstGeom prst="rect">
+            <a:avLst/>
+          </a:prstGeom>
+        </p:spPr>
+      </p:pic>
+      <p:pic>
+        <p:nvPicPr>
+          <p:cNvPr id="160" name="Picture 159">
+            <a:extLst>
+              <a:ext uri="{FF2B5EF4-FFF2-40B4-BE49-F238E27FC236}">
+                <a16:creationId xmlns:a16="http://schemas.microsoft.com/office/drawing/2014/main" id="{66CC7B58-1965-12D9-A0D4-CC6549A5A73F}"/>
+              </a:ext>
+            </a:extLst>
+          </p:cNvPr>
+          <p:cNvPicPr>
+            <a:picLocks noChangeAspect="1"/>
+          </p:cNvPicPr>
+          <p:nvPr/>
+        </p:nvPicPr>
+        <p:blipFill>
+          <a:blip r:embed="rId11"/>
+          <a:stretch>
+            <a:fillRect/>
+          </a:stretch>
+        </p:blipFill>
+        <p:spPr>
+          <a:xfrm>
+            <a:off x="2391635" y="4119372"/>
+            <a:ext cx="611690" cy="611690"/>
+          </a:xfrm>
+          <a:prstGeom prst="rect">
+            <a:avLst/>
+          </a:prstGeom>
+        </p:spPr>
+      </p:pic>
+      <p:pic>
+        <p:nvPicPr>
+          <p:cNvPr id="162" name="Picture 161">
+            <a:extLst>
+              <a:ext uri="{FF2B5EF4-FFF2-40B4-BE49-F238E27FC236}">
+                <a16:creationId xmlns:a16="http://schemas.microsoft.com/office/drawing/2014/main" id="{3ED54AE5-0931-8ED4-D80E-5D1EC5AAEA43}"/>
+              </a:ext>
+            </a:extLst>
+          </p:cNvPr>
+          <p:cNvPicPr>
+            <a:picLocks noChangeAspect="1"/>
+          </p:cNvPicPr>
+          <p:nvPr/>
+        </p:nvPicPr>
+        <p:blipFill>
+          <a:blip r:embed="rId12"/>
+          <a:stretch>
+            <a:fillRect/>
+          </a:stretch>
+        </p:blipFill>
+        <p:spPr>
+          <a:xfrm flipH="1">
+            <a:off x="2554190" y="3347622"/>
+            <a:ext cx="286580" cy="286580"/>
+          </a:xfrm>
+          <a:prstGeom prst="rect">
+            <a:avLst/>
+          </a:prstGeom>
+        </p:spPr>
+      </p:pic>
+      <p:pic>
+        <p:nvPicPr>
+          <p:cNvPr id="164" name="Picture 163">
+            <a:extLst>
+              <a:ext uri="{FF2B5EF4-FFF2-40B4-BE49-F238E27FC236}">
+                <a16:creationId xmlns:a16="http://schemas.microsoft.com/office/drawing/2014/main" id="{EC935893-D19F-9E57-5F62-905506064DDB}"/>
+              </a:ext>
+            </a:extLst>
+          </p:cNvPr>
+          <p:cNvPicPr>
+            <a:picLocks noChangeAspect="1"/>
+          </p:cNvPicPr>
+          <p:nvPr/>
+        </p:nvPicPr>
+        <p:blipFill>
+          <a:blip r:embed="rId13"/>
+          <a:stretch>
+            <a:fillRect/>
+          </a:stretch>
+        </p:blipFill>
+        <p:spPr>
+          <a:xfrm>
+            <a:off x="2539492" y="3730752"/>
+            <a:ext cx="315976" cy="315976"/>
+          </a:xfrm>
+          <a:prstGeom prst="rect">
+            <a:avLst/>
+          </a:prstGeom>
+        </p:spPr>
+      </p:pic>
+      <p:pic>
+        <p:nvPicPr>
+          <p:cNvPr id="166" name="Picture 165">
+            <a:extLst>
+              <a:ext uri="{FF2B5EF4-FFF2-40B4-BE49-F238E27FC236}">
+                <a16:creationId xmlns:a16="http://schemas.microsoft.com/office/drawing/2014/main" id="{5F8050E2-4D4D-B447-ABB7-F48E6B5A6ACB}"/>
+              </a:ext>
+            </a:extLst>
+          </p:cNvPr>
+          <p:cNvPicPr>
+            <a:picLocks noChangeAspect="1"/>
+          </p:cNvPicPr>
+          <p:nvPr/>
+        </p:nvPicPr>
+        <p:blipFill>
+          <a:blip r:embed="rId14"/>
+          <a:stretch>
+            <a:fillRect/>
+          </a:stretch>
+        </p:blipFill>
+        <p:spPr>
+          <a:xfrm>
+            <a:off x="2458789" y="4701921"/>
+            <a:ext cx="435102" cy="435102"/>
+          </a:xfrm>
+          <a:prstGeom prst="rect">
+            <a:avLst/>
+          </a:prstGeom>
+        </p:spPr>
+      </p:pic>
+      <p:sp>
+        <p:nvSpPr>
+          <p:cNvPr id="167" name="Circular Arrow 166">
+            <a:extLst>
+              <a:ext uri="{FF2B5EF4-FFF2-40B4-BE49-F238E27FC236}">
+                <a16:creationId xmlns:a16="http://schemas.microsoft.com/office/drawing/2014/main" id="{65052AFD-6385-40AF-4071-5DB6B3D2FB12}"/>
+              </a:ext>
+            </a:extLst>
+          </p:cNvPr>
+          <p:cNvSpPr/>
+          <p:nvPr/>
+        </p:nvSpPr>
+        <p:spPr>
+          <a:xfrm rot="5400000">
+            <a:off x="2683529" y="3089311"/>
+            <a:ext cx="439382" cy="411480"/>
+          </a:xfrm>
+          <a:prstGeom prst="circularArrow">
+            <a:avLst>
+              <a:gd name="adj1" fmla="val 12500"/>
+              <a:gd name="adj2" fmla="val 714327"/>
+              <a:gd name="adj3" fmla="val 20457681"/>
+              <a:gd name="adj4" fmla="val 10800000"/>
+              <a:gd name="adj5" fmla="val 14940"/>
+            </a:avLst>
+          </a:prstGeom>
+          <a:solidFill>
+            <a:srgbClr val="253E85"/>
+          </a:solidFill>
+          <a:ln>
+            <a:solidFill>
+              <a:srgbClr val="253E85"/>
+            </a:solidFill>
+          </a:ln>
+        </p:spPr>
+        <p:style>
+          <a:lnRef idx="2">
+            <a:schemeClr val="accent1">
+              <a:shade val="15000"/>
+            </a:schemeClr>
+          </a:lnRef>
+          <a:fillRef idx="1">
+            <a:schemeClr val="accent1"/>
+          </a:fillRef>
+          <a:effectRef idx="0">
+            <a:schemeClr val="accent1"/>
+          </a:effectRef>
+          <a:fontRef idx="minor">
+            <a:schemeClr val="lt1"/>
+          </a:fontRef>
+        </p:style>
+        <p:txBody>
+          <a:bodyPr rtlCol="0" anchor="ctr"/>
+          <a:lstStyle/>
+          <a:p>
+            <a:pPr algn="ctr"/>
+            <a:endParaRPr lang="en-US">
+              <a:solidFill>
+                <a:schemeClr val="tx1"/>
+              </a:solidFill>
+            </a:endParaRPr>
+          </a:p>
+        </p:txBody>
+      </p:sp>
+      <p:sp>
+        <p:nvSpPr>
+          <p:cNvPr id="168" name="Circular Arrow 167">
+            <a:extLst>
+              <a:ext uri="{FF2B5EF4-FFF2-40B4-BE49-F238E27FC236}">
+                <a16:creationId xmlns:a16="http://schemas.microsoft.com/office/drawing/2014/main" id="{47640858-DD3C-0DD1-07E3-736956EF6EB7}"/>
+              </a:ext>
+            </a:extLst>
+          </p:cNvPr>
+          <p:cNvSpPr/>
+          <p:nvPr/>
+        </p:nvSpPr>
+        <p:spPr>
+          <a:xfrm rot="5400000">
+            <a:off x="2683529" y="3903625"/>
+            <a:ext cx="439382" cy="411480"/>
+          </a:xfrm>
+          <a:prstGeom prst="circularArrow">
+            <a:avLst>
+              <a:gd name="adj1" fmla="val 12500"/>
+              <a:gd name="adj2" fmla="val 714327"/>
+              <a:gd name="adj3" fmla="val 20457681"/>
+              <a:gd name="adj4" fmla="val 10800000"/>
+              <a:gd name="adj5" fmla="val 14940"/>
+            </a:avLst>
+          </a:prstGeom>
+          <a:solidFill>
+            <a:srgbClr val="253E85"/>
+          </a:solidFill>
+          <a:ln>
+            <a:solidFill>
+              <a:srgbClr val="253E85"/>
+            </a:solidFill>
+          </a:ln>
+        </p:spPr>
+        <p:style>
+          <a:lnRef idx="2">
+            <a:schemeClr val="accent1">
+              <a:shade val="15000"/>
+            </a:schemeClr>
+          </a:lnRef>
+          <a:fillRef idx="1">
+            <a:schemeClr val="accent1"/>
+          </a:fillRef>
+          <a:effectRef idx="0">
+            <a:schemeClr val="accent1"/>
+          </a:effectRef>
+          <a:fontRef idx="minor">
+            <a:schemeClr val="lt1"/>
+          </a:fontRef>
+        </p:style>
+        <p:txBody>
+          <a:bodyPr rtlCol="0" anchor="ctr"/>
+          <a:lstStyle/>
+          <a:p>
+            <a:pPr algn="ctr"/>
+            <a:endParaRPr lang="en-US">
+              <a:solidFill>
+                <a:schemeClr val="tx1"/>
+              </a:solidFill>
+            </a:endParaRPr>
+          </a:p>
+        </p:txBody>
+      </p:sp>
+      <p:sp>
+        <p:nvSpPr>
+          <p:cNvPr id="169" name="Circular Arrow 168">
+            <a:extLst>
+              <a:ext uri="{FF2B5EF4-FFF2-40B4-BE49-F238E27FC236}">
+                <a16:creationId xmlns:a16="http://schemas.microsoft.com/office/drawing/2014/main" id="{9261A041-5911-706D-9F0D-6A111BBB7655}"/>
+              </a:ext>
+            </a:extLst>
+          </p:cNvPr>
+          <p:cNvSpPr/>
+          <p:nvPr/>
+        </p:nvSpPr>
+        <p:spPr>
+          <a:xfrm rot="16200000" flipH="1">
+            <a:off x="2242871" y="3450716"/>
+            <a:ext cx="439382" cy="411480"/>
+          </a:xfrm>
+          <a:prstGeom prst="circularArrow">
+            <a:avLst>
+              <a:gd name="adj1" fmla="val 12500"/>
+              <a:gd name="adj2" fmla="val 714327"/>
+              <a:gd name="adj3" fmla="val 20457681"/>
+              <a:gd name="adj4" fmla="val 10800000"/>
+              <a:gd name="adj5" fmla="val 14940"/>
+            </a:avLst>
+          </a:prstGeom>
+          <a:solidFill>
+            <a:srgbClr val="253E85"/>
+          </a:solidFill>
+          <a:ln>
+            <a:solidFill>
+              <a:srgbClr val="253E85"/>
+            </a:solidFill>
+          </a:ln>
+        </p:spPr>
+        <p:style>
+          <a:lnRef idx="2">
+            <a:schemeClr val="accent1">
+              <a:shade val="15000"/>
+            </a:schemeClr>
+          </a:lnRef>
+          <a:fillRef idx="1">
+            <a:schemeClr val="accent1"/>
+          </a:fillRef>
+          <a:effectRef idx="0">
+            <a:schemeClr val="accent1"/>
+          </a:effectRef>
+          <a:fontRef idx="minor">
+            <a:schemeClr val="lt1"/>
+          </a:fontRef>
+        </p:style>
+        <p:txBody>
+          <a:bodyPr rtlCol="0" anchor="ctr"/>
+          <a:lstStyle/>
+          <a:p>
+            <a:pPr algn="ctr"/>
+            <a:endParaRPr lang="en-US" dirty="0">
+              <a:solidFill>
+                <a:schemeClr val="tx1"/>
+              </a:solidFill>
+            </a:endParaRPr>
+          </a:p>
+        </p:txBody>
+      </p:sp>
+      <p:sp>
+        <p:nvSpPr>
+          <p:cNvPr id="170" name="Circular Arrow 169">
+            <a:extLst>
+              <a:ext uri="{FF2B5EF4-FFF2-40B4-BE49-F238E27FC236}">
+                <a16:creationId xmlns:a16="http://schemas.microsoft.com/office/drawing/2014/main" id="{897B9757-411B-A8A4-3588-D5F8D5F38381}"/>
+              </a:ext>
+            </a:extLst>
+          </p:cNvPr>
+          <p:cNvSpPr/>
+          <p:nvPr/>
+        </p:nvSpPr>
+        <p:spPr>
+          <a:xfrm rot="16200000" flipH="1">
+            <a:off x="2194411" y="4534954"/>
+            <a:ext cx="439382" cy="411480"/>
+          </a:xfrm>
+          <a:prstGeom prst="circularArrow">
+            <a:avLst>
+              <a:gd name="adj1" fmla="val 12500"/>
+              <a:gd name="adj2" fmla="val 1061410"/>
+              <a:gd name="adj3" fmla="val 20457681"/>
+              <a:gd name="adj4" fmla="val 10800000"/>
+              <a:gd name="adj5" fmla="val 14940"/>
+            </a:avLst>
+          </a:prstGeom>
+          <a:solidFill>
+            <a:srgbClr val="253E85"/>
+          </a:solidFill>
+          <a:ln>
+            <a:solidFill>
+              <a:srgbClr val="253E85"/>
+            </a:solidFill>
+          </a:ln>
+        </p:spPr>
+        <p:style>
+          <a:lnRef idx="2">
+            <a:schemeClr val="accent1">
+              <a:shade val="15000"/>
+            </a:schemeClr>
+          </a:lnRef>
+          <a:fillRef idx="1">
+            <a:schemeClr val="accent1"/>
+          </a:fillRef>
+          <a:effectRef idx="0">
+            <a:schemeClr val="accent1"/>
+          </a:effectRef>
+          <a:fontRef idx="minor">
+            <a:schemeClr val="lt1"/>
+          </a:fontRef>
+        </p:style>
+        <p:txBody>
+          <a:bodyPr rtlCol="0" anchor="ctr"/>
+          <a:lstStyle/>
+          <a:p>
+            <a:pPr algn="ctr"/>
+            <a:endParaRPr lang="en-US" dirty="0">
+              <a:solidFill>
+                <a:schemeClr val="tx1"/>
+              </a:solidFill>
+            </a:endParaRPr>
           </a:p>
         </p:txBody>
       </p:sp>

</xml_diff>